<commit_message>
Updated homepage with R_Forest
</commit_message>
<xml_diff>
--- a/R_Forests/Toy diagrams.pptx
+++ b/R_Forests/Toy diagrams.pptx
@@ -4332,6 +4332,11 @@
           <a:prstGeom prst="ellipse">
             <a:avLst/>
           </a:prstGeom>
+          <a:solidFill>
+            <a:schemeClr val="accent6">
+              <a:lumMod val="75000"/>
+            </a:schemeClr>
+          </a:solidFill>
         </p:spPr>
         <p:style>
           <a:lnRef idx="2">
@@ -4528,6 +4533,11 @@
           <a:prstGeom prst="ellipse">
             <a:avLst/>
           </a:prstGeom>
+          <a:solidFill>
+            <a:schemeClr val="accent6">
+              <a:lumMod val="75000"/>
+            </a:schemeClr>
+          </a:solidFill>
         </p:spPr>
         <p:style>
           <a:lnRef idx="2">
@@ -4931,6 +4941,11 @@
           <a:prstGeom prst="ellipse">
             <a:avLst/>
           </a:prstGeom>
+          <a:solidFill>
+            <a:schemeClr val="accent6">
+              <a:lumMod val="75000"/>
+            </a:schemeClr>
+          </a:solidFill>
         </p:spPr>
         <p:style>
           <a:lnRef idx="2">
@@ -4980,6 +4995,11 @@
           <a:prstGeom prst="ellipse">
             <a:avLst/>
           </a:prstGeom>
+          <a:solidFill>
+            <a:schemeClr val="accent6">
+              <a:lumMod val="75000"/>
+            </a:schemeClr>
+          </a:solidFill>
         </p:spPr>
         <p:style>
           <a:lnRef idx="2">

</xml_diff>